<commit_message>
Kit: modelo editável ajustado ao Canva (posição vertical e nomes de fonte reconhecidos)
Co-Authored-By: Claude Sonnet 5.5 <noreply@anthropic.com>
Claude-Session: https://claude.ai/code/session_01Ybqv1noxS4Amss8ezpWAyE
</commit_message>
<xml_diff>
--- a/entregas/posts/site/kit/editavel/efeito-rebote-09-a-13-11.pptx
+++ b/entregas/posts/site/kit/editavel/efeito-rebote-09-a-13-11.pptx
@@ -4049,7 +4049,7 @@
         </p:nvSpPr>
         <p:spPr>
           <a:xfrm>
-            <a:off x="915442" y="4781344"/>
+            <a:off x="915442" y="4720445"/>
             <a:ext cx="2182832" cy="304495"/>
           </a:xfrm>
           <a:prstGeom prst="rect">
@@ -4075,13 +4075,13 @@
               </a:spcAft>
             </a:pPr>
             <a:r>
-              <a:rPr b="0" i="0" sz="2397" lang="pt-BR">
+              <a:rPr b="1" i="0" sz="2397" lang="pt-BR">
                 <a:solidFill>
                   <a:srgbClr val="E9C46A"/>
                 </a:solidFill>
-                <a:latin typeface="Barlow SemiBold"/>
-                <a:ea typeface="Barlow SemiBold"/>
-                <a:cs typeface="Barlow SemiBold"/>
+                <a:latin typeface="Barlow"/>
+                <a:ea typeface="Barlow"/>
+                <a:cs typeface="Barlow"/>
               </a:rPr>
               <a:t>Transparência</a:t>
             </a:r>
@@ -4096,7 +4096,7 @@
         </p:nvSpPr>
         <p:spPr>
           <a:xfrm>
-            <a:off x="915442" y="5536791"/>
+            <a:off x="915442" y="5260690"/>
             <a:ext cx="4979506" cy="2459831"/>
           </a:xfrm>
           <a:prstGeom prst="rect">
@@ -4155,7 +4155,7 @@
         </p:nvSpPr>
         <p:spPr>
           <a:xfrm>
-            <a:off x="915442" y="8180317"/>
+            <a:off x="915442" y="8220334"/>
             <a:ext cx="5582251" cy="1040427"/>
           </a:xfrm>
           <a:prstGeom prst="rect">
@@ -4202,7 +4202,7 @@
         </p:nvSpPr>
         <p:spPr>
           <a:xfrm>
-            <a:off x="915442" y="11515488"/>
+            <a:off x="915442" y="11496457"/>
             <a:ext cx="1210717" cy="437712"/>
           </a:xfrm>
           <a:prstGeom prst="rect">
@@ -4470,7 +4470,7 @@
         </p:nvSpPr>
         <p:spPr>
           <a:xfrm>
-            <a:off x="915442" y="1079840"/>
+            <a:off x="915442" y="1018941"/>
             <a:ext cx="1071563" cy="304495"/>
           </a:xfrm>
           <a:prstGeom prst="rect">
@@ -4496,13 +4496,13 @@
               </a:spcAft>
             </a:pPr>
             <a:r>
-              <a:rPr b="0" i="0" sz="2397" lang="pt-BR">
+              <a:rPr b="1" i="0" sz="2397" lang="pt-BR">
                 <a:solidFill>
                   <a:srgbClr val="B5121B"/>
                 </a:solidFill>
-                <a:latin typeface="Barlow SemiBold"/>
-                <a:ea typeface="Barlow SemiBold"/>
-                <a:cs typeface="Barlow SemiBold"/>
+                <a:latin typeface="Barlow"/>
+                <a:ea typeface="Barlow"/>
+                <a:cs typeface="Barlow"/>
               </a:rPr>
               <a:t>Entrou</a:t>
             </a:r>
@@ -4517,7 +4517,7 @@
         </p:nvSpPr>
         <p:spPr>
           <a:xfrm>
-            <a:off x="915442" y="4461891"/>
+            <a:off x="915442" y="3460966"/>
             <a:ext cx="7053560" cy="2430818"/>
           </a:xfrm>
           <a:prstGeom prst="rect">
@@ -4564,7 +4564,7 @@
         </p:nvSpPr>
         <p:spPr>
           <a:xfrm>
-            <a:off x="915442" y="6850841"/>
+            <a:off x="915442" y="6691517"/>
             <a:ext cx="5440353" cy="1419442"/>
           </a:xfrm>
           <a:prstGeom prst="rect">
@@ -4623,7 +4623,7 @@
         </p:nvSpPr>
         <p:spPr>
           <a:xfrm>
-            <a:off x="915442" y="8550152"/>
+            <a:off x="915442" y="8587185"/>
             <a:ext cx="5718006" cy="333299"/>
           </a:xfrm>
           <a:prstGeom prst="rect">
@@ -4670,7 +4670,7 @@
         </p:nvSpPr>
         <p:spPr>
           <a:xfrm>
-            <a:off x="915442" y="11515488"/>
+            <a:off x="915442" y="11496457"/>
             <a:ext cx="2303324" cy="437712"/>
           </a:xfrm>
           <a:prstGeom prst="rect">
@@ -4914,7 +4914,7 @@
         </p:nvSpPr>
         <p:spPr>
           <a:xfrm>
-            <a:off x="915442" y="1079840"/>
+            <a:off x="915442" y="1018941"/>
             <a:ext cx="713690" cy="304495"/>
           </a:xfrm>
           <a:prstGeom prst="rect">
@@ -4940,13 +4940,13 @@
               </a:spcAft>
             </a:pPr>
             <a:r>
-              <a:rPr b="0" i="0" sz="2397" lang="pt-BR">
+              <a:rPr b="1" i="0" sz="2397" lang="pt-BR">
                 <a:solidFill>
                   <a:srgbClr val="B5121B"/>
                 </a:solidFill>
-                <a:latin typeface="Barlow SemiBold"/>
-                <a:ea typeface="Barlow SemiBold"/>
-                <a:cs typeface="Barlow SemiBold"/>
+                <a:latin typeface="Barlow"/>
+                <a:ea typeface="Barlow"/>
+                <a:cs typeface="Barlow"/>
               </a:rPr>
               <a:t>Saiu</a:t>
             </a:r>
@@ -4961,7 +4961,7 @@
         </p:nvSpPr>
         <p:spPr>
           <a:xfrm>
-            <a:off x="915442" y="4816697"/>
+            <a:off x="915442" y="3815772"/>
             <a:ext cx="7053560" cy="2430818"/>
           </a:xfrm>
           <a:prstGeom prst="rect">
@@ -5008,7 +5008,7 @@
         </p:nvSpPr>
         <p:spPr>
           <a:xfrm>
-            <a:off x="915442" y="7205647"/>
+            <a:off x="915442" y="7046323"/>
             <a:ext cx="8870588" cy="709721"/>
           </a:xfrm>
           <a:prstGeom prst="rect">
@@ -5055,7 +5055,7 @@
         </p:nvSpPr>
         <p:spPr>
           <a:xfrm>
-            <a:off x="915442" y="8195346"/>
+            <a:off x="915442" y="8232379"/>
             <a:ext cx="3256940" cy="333299"/>
           </a:xfrm>
           <a:prstGeom prst="rect">
@@ -5102,7 +5102,7 @@
         </p:nvSpPr>
         <p:spPr>
           <a:xfrm>
-            <a:off x="915442" y="11515488"/>
+            <a:off x="915442" y="11496457"/>
             <a:ext cx="3281988" cy="437712"/>
           </a:xfrm>
           <a:prstGeom prst="rect">
@@ -5532,7 +5532,7 @@
         </p:nvSpPr>
         <p:spPr>
           <a:xfrm>
-            <a:off x="915442" y="1079840"/>
+            <a:off x="915442" y="1018941"/>
             <a:ext cx="1431563" cy="304495"/>
           </a:xfrm>
           <a:prstGeom prst="rect">
@@ -5558,13 +5558,13 @@
               </a:spcAft>
             </a:pPr>
             <a:r>
-              <a:rPr b="0" i="0" sz="2397" lang="pt-BR">
+              <a:rPr b="1" i="0" sz="2397" lang="pt-BR">
                 <a:solidFill>
                   <a:srgbClr val="B5121B"/>
                 </a:solidFill>
-                <a:latin typeface="Barlow SemiBold"/>
-                <a:ea typeface="Barlow SemiBold"/>
-                <a:cs typeface="Barlow SemiBold"/>
+                <a:latin typeface="Barlow"/>
+                <a:ea typeface="Barlow"/>
+                <a:cs typeface="Barlow"/>
               </a:rPr>
               <a:t>Entregue</a:t>
             </a:r>
@@ -5579,7 +5579,7 @@
         </p:nvSpPr>
         <p:spPr>
           <a:xfrm>
-            <a:off x="915442" y="3792707"/>
+            <a:off x="915442" y="3583140"/>
             <a:ext cx="6425565" cy="933524"/>
           </a:xfrm>
           <a:prstGeom prst="rect">
@@ -5626,7 +5626,7 @@
         </p:nvSpPr>
         <p:spPr>
           <a:xfrm>
-            <a:off x="1488378" y="5173587"/>
+            <a:off x="1488378" y="5402987"/>
             <a:ext cx="195218" cy="686143"/>
           </a:xfrm>
           <a:prstGeom prst="rect">
@@ -5673,7 +5673,7 @@
         </p:nvSpPr>
         <p:spPr>
           <a:xfrm>
-            <a:off x="2175867" y="5348416"/>
+            <a:off x="2175867" y="5388432"/>
             <a:ext cx="3659669" cy="520214"/>
           </a:xfrm>
           <a:prstGeom prst="rect">
@@ -5720,7 +5720,7 @@
         </p:nvSpPr>
         <p:spPr>
           <a:xfrm>
-            <a:off x="1456283" y="6638353"/>
+            <a:off x="1456283" y="6867754"/>
             <a:ext cx="259556" cy="686143"/>
           </a:xfrm>
           <a:prstGeom prst="rect">
@@ -5767,7 +5767,7 @@
         </p:nvSpPr>
         <p:spPr>
           <a:xfrm>
-            <a:off x="2175867" y="6813182"/>
+            <a:off x="2175867" y="6853199"/>
             <a:ext cx="3667199" cy="520214"/>
           </a:xfrm>
           <a:prstGeom prst="rect">
@@ -5814,7 +5814,7 @@
         </p:nvSpPr>
         <p:spPr>
           <a:xfrm>
-            <a:off x="1456618" y="8103120"/>
+            <a:off x="1456618" y="8332520"/>
             <a:ext cx="258738" cy="686143"/>
           </a:xfrm>
           <a:prstGeom prst="rect">
@@ -5861,7 +5861,7 @@
         </p:nvSpPr>
         <p:spPr>
           <a:xfrm>
-            <a:off x="2175867" y="8277949"/>
+            <a:off x="2175867" y="8317965"/>
             <a:ext cx="3774430" cy="520214"/>
           </a:xfrm>
           <a:prstGeom prst="rect">
@@ -5908,7 +5908,7 @@
         </p:nvSpPr>
         <p:spPr>
           <a:xfrm>
-            <a:off x="915442" y="11515488"/>
+            <a:off x="915442" y="11496457"/>
             <a:ext cx="1849517" cy="437712"/>
           </a:xfrm>
           <a:prstGeom prst="rect">
@@ -6036,7 +6036,7 @@
         </p:nvSpPr>
         <p:spPr>
           <a:xfrm>
-            <a:off x="4436313" y="5897555"/>
+            <a:off x="4436313" y="5836656"/>
             <a:ext cx="1414373" cy="304495"/>
           </a:xfrm>
           <a:prstGeom prst="rect">
@@ -6062,13 +6062,13 @@
               </a:spcAft>
             </a:pPr>
             <a:r>
-              <a:rPr b="0" i="0" sz="2397" lang="pt-BR">
+              <a:rPr b="1" i="0" sz="2397" lang="pt-BR">
                 <a:solidFill>
                   <a:srgbClr val="E9C46A"/>
                 </a:solidFill>
-                <a:latin typeface="Barlow SemiBold"/>
-                <a:ea typeface="Barlow SemiBold"/>
-                <a:cs typeface="Barlow SemiBold"/>
+                <a:latin typeface="Barlow"/>
+                <a:ea typeface="Barlow"/>
+                <a:cs typeface="Barlow"/>
               </a:rPr>
               <a:t>Obrigado</a:t>
             </a:r>
@@ -6083,7 +6083,7 @@
         </p:nvSpPr>
         <p:spPr>
           <a:xfrm>
-            <a:off x="2295302" y="6666281"/>
+            <a:off x="2295302" y="6456714"/>
             <a:ext cx="5696396" cy="933524"/>
           </a:xfrm>
           <a:prstGeom prst="rect">
@@ -6130,7 +6130,7 @@
         </p:nvSpPr>
         <p:spPr>
           <a:xfrm>
-            <a:off x="2531872" y="8204135"/>
+            <a:off x="2531872" y="8105380"/>
             <a:ext cx="5223108" cy="493776"/>
           </a:xfrm>
           <a:prstGeom prst="rect">

</xml_diff>